<commit_message>
deck: add GitHub handle to team slide; refresh 14p decks, PDFs, pack
</commit_message>
<xml_diff>
--- a/submit/01_TeaWindow_Pitch_EN_14p.pptx
+++ b/submit/01_TeaWindow_Pitch_EN_14p.pptx
@@ -11,7 +11,7 @@
   </p:notesMasterIdLst>
   <p:sldIdLst>
     <p:sldId id="256" r:id="rId4"/>
-    <p:sldId id="269" r:id="rId22"/>
+    <p:sldId id="268" r:id="rId21"/>
     <p:sldId id="257" r:id="rId5"/>
     <p:sldId id="258" r:id="rId6"/>
     <p:sldId id="259" r:id="rId7"/>
@@ -23,7 +23,7 @@
     <p:sldId id="265" r:id="rId13"/>
     <p:sldId id="266" r:id="rId14"/>
     <p:sldId id="267" r:id="rId15"/>
-    <p:sldId id="268" r:id="rId21"/>
+    <p:sldId id="269" r:id="rId22"/>
   </p:sldIdLst>
   <p:sldSz cx="12179300" cy="6858000"/>
   <p:notesSz cx="6858000" cy="9144000"/>
@@ -22214,30 +22214,735 @@
         <p:nvPr/>
       </p:nvGrpSpPr>
       <p:grpSpPr/>
-      <p:pic>
-        <p:nvPicPr>
-          <p:cNvPr id="2" name="Picture 1" descr="30_architecture_1plus5_EN.png"/>
-          <p:cNvPicPr>
-            <a:picLocks noChangeAspect="1"/>
-          </p:cNvPicPr>
+      <p:sp>
+        <p:nvSpPr>
+          <p:cNvPr id="2" name="Rectangle 1"/>
+          <p:cNvSpPr/>
           <p:nvPr/>
-        </p:nvPicPr>
-        <p:blipFill>
-          <a:blip r:embed="rId2"/>
-          <a:stretch>
-            <a:fillRect/>
-          </a:stretch>
-        </p:blipFill>
+        </p:nvSpPr>
         <p:spPr>
           <a:xfrm>
             <a:off x="0" y="0"/>
-            <a:ext cx="12179300" cy="6858000"/>
+            <a:ext cx="12179808" cy="6858000"/>
           </a:xfrm>
           <a:prstGeom prst="rect">
             <a:avLst/>
           </a:prstGeom>
-        </p:spPr>
-      </p:pic>
+          <a:solidFill>
+            <a:srgbClr val="0F1720"/>
+          </a:solidFill>
+          <a:ln>
+            <a:noFill/>
+          </a:ln>
+          <a:effectLst/>
+        </p:spPr>
+        <p:style>
+          <a:lnRef idx="1">
+            <a:schemeClr val="accent1"/>
+          </a:lnRef>
+          <a:fillRef idx="3">
+            <a:schemeClr val="accent1"/>
+          </a:fillRef>
+          <a:effectRef idx="2">
+            <a:schemeClr val="accent1"/>
+          </a:effectRef>
+          <a:fontRef idx="minor">
+            <a:schemeClr val="lt1"/>
+          </a:fontRef>
+        </p:style>
+        <p:txBody>
+          <a:bodyPr rtlCol="0" anchor="ctr"/>
+          <a:lstStyle/>
+          <a:p>
+            <a:pPr algn="ctr"/>
+          </a:p>
+        </p:txBody>
+      </p:sp>
+      <p:sp>
+        <p:nvSpPr>
+          <p:cNvPr id="3" name="Rectangle 2"/>
+          <p:cNvSpPr/>
+          <p:nvPr/>
+        </p:nvSpPr>
+        <p:spPr>
+          <a:xfrm>
+            <a:off x="640080" y="658368"/>
+            <a:ext cx="64008" cy="777240"/>
+          </a:xfrm>
+          <a:prstGeom prst="rect">
+            <a:avLst/>
+          </a:prstGeom>
+          <a:solidFill>
+            <a:srgbClr val="4AA8FF"/>
+          </a:solidFill>
+          <a:ln>
+            <a:noFill/>
+          </a:ln>
+          <a:effectLst/>
+        </p:spPr>
+        <p:style>
+          <a:lnRef idx="1">
+            <a:schemeClr val="accent1"/>
+          </a:lnRef>
+          <a:fillRef idx="3">
+            <a:schemeClr val="accent1"/>
+          </a:fillRef>
+          <a:effectRef idx="2">
+            <a:schemeClr val="accent1"/>
+          </a:effectRef>
+          <a:fontRef idx="minor">
+            <a:schemeClr val="lt1"/>
+          </a:fontRef>
+        </p:style>
+        <p:txBody>
+          <a:bodyPr rtlCol="0" anchor="ctr"/>
+          <a:lstStyle/>
+          <a:p>
+            <a:pPr algn="ctr"/>
+          </a:p>
+        </p:txBody>
+      </p:sp>
+      <p:sp>
+        <p:nvSpPr>
+          <p:cNvPr id="4" name="TextBox 3"/>
+          <p:cNvSpPr txBox="1"/>
+          <p:nvPr/>
+        </p:nvSpPr>
+        <p:spPr>
+          <a:xfrm>
+            <a:off x="868680" y="621792"/>
+            <a:ext cx="8229600" cy="640080"/>
+          </a:xfrm>
+          <a:prstGeom prst="rect">
+            <a:avLst/>
+          </a:prstGeom>
+          <a:noFill/>
+        </p:spPr>
+        <p:txBody>
+          <a:bodyPr wrap="square">
+            <a:spAutoFit/>
+          </a:bodyPr>
+          <a:lstStyle/>
+          <a:p>
+            <a:pPr algn="l"/>
+            <a:r>
+              <a:rPr sz="3000" b="1" i="0">
+                <a:solidFill>
+                  <a:srgbClr val="E8EEF3"/>
+                </a:solidFill>
+                <a:latin typeface="Montserrat"/>
+              </a:rPr>
+              <a:t>Team &amp; background</a:t>
+            </a:r>
+          </a:p>
+        </p:txBody>
+      </p:sp>
+      <p:sp>
+        <p:nvSpPr>
+          <p:cNvPr id="5" name="TextBox 4"/>
+          <p:cNvSpPr txBox="1"/>
+          <p:nvPr/>
+        </p:nvSpPr>
+        <p:spPr>
+          <a:xfrm>
+            <a:off x="868680" y="1481328"/>
+            <a:ext cx="5486400" cy="731520"/>
+          </a:xfrm>
+          <a:prstGeom prst="rect">
+            <a:avLst/>
+          </a:prstGeom>
+          <a:noFill/>
+        </p:spPr>
+        <p:txBody>
+          <a:bodyPr wrap="square">
+            <a:spAutoFit/>
+          </a:bodyPr>
+          <a:lstStyle/>
+          <a:p>
+            <a:pPr algn="l"/>
+            <a:r>
+              <a:rPr sz="4000" b="1" i="0">
+                <a:solidFill>
+                  <a:srgbClr val="E8EEF3"/>
+                </a:solidFill>
+                <a:latin typeface="Montserrat"/>
+              </a:rPr>
+              <a:t>Ye Zixuan</a:t>
+            </a:r>
+          </a:p>
+        </p:txBody>
+      </p:sp>
+      <p:sp>
+        <p:nvSpPr>
+          <p:cNvPr id="6" name="TextBox 5"/>
+          <p:cNvSpPr txBox="1"/>
+          <p:nvPr/>
+        </p:nvSpPr>
+        <p:spPr>
+          <a:xfrm>
+            <a:off x="868680" y="2148840"/>
+            <a:ext cx="5486400" cy="365760"/>
+          </a:xfrm>
+          <a:prstGeom prst="rect">
+            <a:avLst/>
+          </a:prstGeom>
+          <a:noFill/>
+        </p:spPr>
+        <p:txBody>
+          <a:bodyPr wrap="square">
+            <a:spAutoFit/>
+          </a:bodyPr>
+          <a:lstStyle/>
+          <a:p>
+            <a:pPr algn="l"/>
+            <a:r>
+              <a:rPr sz="1800" b="0" i="0">
+                <a:solidFill>
+                  <a:srgbClr val="9FB4C6"/>
+                </a:solidFill>
+                <a:latin typeface="Montserrat"/>
+              </a:rPr>
+              <a:t>叶子玄</a:t>
+            </a:r>
+          </a:p>
+        </p:txBody>
+      </p:sp>
+      <p:sp>
+        <p:nvSpPr>
+          <p:cNvPr id="7" name="TextBox 6"/>
+          <p:cNvSpPr txBox="1"/>
+          <p:nvPr/>
+        </p:nvSpPr>
+        <p:spPr>
+          <a:xfrm>
+            <a:off x="868680" y="2606040"/>
+            <a:ext cx="5669280" cy="457200"/>
+          </a:xfrm>
+          <a:prstGeom prst="rect">
+            <a:avLst/>
+          </a:prstGeom>
+          <a:noFill/>
+        </p:spPr>
+        <p:txBody>
+          <a:bodyPr wrap="square">
+            <a:spAutoFit/>
+          </a:bodyPr>
+          <a:lstStyle/>
+          <a:p>
+            <a:pPr algn="l"/>
+            <a:r>
+              <a:rPr sz="1600" b="0" i="0">
+                <a:solidFill>
+                  <a:srgbClr val="CED9E4"/>
+                </a:solidFill>
+                <a:latin typeface="Inter"/>
+              </a:rPr>
+              <a:t>Zhejiang University · Computer Science and Technology (BSc, Year 2)</a:t>
+            </a:r>
+          </a:p>
+        </p:txBody>
+      </p:sp>
+      <p:sp>
+        <p:nvSpPr>
+          <p:cNvPr id="8" name="TextBox 7"/>
+          <p:cNvSpPr txBox="1"/>
+          <p:nvPr/>
+        </p:nvSpPr>
+        <p:spPr>
+          <a:xfrm>
+            <a:off x="868680" y="3200400"/>
+            <a:ext cx="5669280" cy="365760"/>
+          </a:xfrm>
+          <a:prstGeom prst="rect">
+            <a:avLst/>
+          </a:prstGeom>
+          <a:noFill/>
+        </p:spPr>
+        <p:txBody>
+          <a:bodyPr wrap="square">
+            <a:spAutoFit/>
+          </a:bodyPr>
+          <a:lstStyle/>
+          <a:p>
+            <a:pPr algn="l"/>
+            <a:r>
+              <a:rPr sz="1350" b="0" i="0">
+                <a:solidFill>
+                  <a:srgbClr val="CED9E4"/>
+                </a:solidFill>
+                <a:latin typeface="Inter"/>
+              </a:rPr>
+              <a:t>Role: project lead · algorithms &amp; full-stack</a:t>
+            </a:r>
+          </a:p>
+        </p:txBody>
+      </p:sp>
+      <p:sp>
+        <p:nvSpPr>
+          <p:cNvPr id="9" name="TextBox 8"/>
+          <p:cNvSpPr txBox="1"/>
+          <p:nvPr/>
+        </p:nvSpPr>
+        <p:spPr>
+          <a:xfrm>
+            <a:off x="868680" y="3493008"/>
+            <a:ext cx="5669280" cy="365760"/>
+          </a:xfrm>
+          <a:prstGeom prst="rect">
+            <a:avLst/>
+          </a:prstGeom>
+          <a:noFill/>
+        </p:spPr>
+        <p:txBody>
+          <a:bodyPr wrap="square">
+            <a:spAutoFit/>
+          </a:bodyPr>
+          <a:lstStyle/>
+          <a:p>
+            <a:pPr algn="l"/>
+            <a:r>
+              <a:rPr sz="1350" b="0" i="0">
+                <a:solidFill>
+                  <a:srgbClr val="CED9E4"/>
+                </a:solidFill>
+                <a:latin typeface="Inter"/>
+              </a:rPr>
+              <a:t>Team: solo (1 person) · age 19</a:t>
+            </a:r>
+          </a:p>
+        </p:txBody>
+      </p:sp>
+      <p:sp>
+        <p:nvSpPr>
+          <p:cNvPr id="10" name="TextBox 9"/>
+          <p:cNvSpPr txBox="1"/>
+          <p:nvPr/>
+        </p:nvSpPr>
+        <p:spPr>
+          <a:xfrm>
+            <a:off x="868680" y="3785615"/>
+            <a:ext cx="5669280" cy="365760"/>
+          </a:xfrm>
+          <a:prstGeom prst="rect">
+            <a:avLst/>
+          </a:prstGeom>
+          <a:noFill/>
+        </p:spPr>
+        <p:txBody>
+          <a:bodyPr wrap="square">
+            <a:spAutoFit/>
+          </a:bodyPr>
+          <a:lstStyle/>
+          <a:p>
+            <a:pPr algn="l"/>
+            <a:r>
+              <a:rPr sz="1350" b="0" i="0">
+                <a:solidFill>
+                  <a:srgbClr val="CED9E4"/>
+                </a:solidFill>
+                <a:latin typeface="Inter"/>
+              </a:rPr>
+              <a:t>Location: Hangzhou, China</a:t>
+            </a:r>
+          </a:p>
+        </p:txBody>
+      </p:sp>
+      <p:sp>
+        <p:nvSpPr>
+          <p:cNvPr id="11" name="TextBox 10"/>
+          <p:cNvSpPr txBox="1"/>
+          <p:nvPr/>
+        </p:nvSpPr>
+        <p:spPr>
+          <a:xfrm>
+            <a:off x="868680" y="4078224"/>
+            <a:ext cx="5669280" cy="365760"/>
+          </a:xfrm>
+          <a:prstGeom prst="rect">
+            <a:avLst/>
+          </a:prstGeom>
+          <a:noFill/>
+        </p:spPr>
+        <p:txBody>
+          <a:bodyPr wrap="square">
+            <a:spAutoFit/>
+          </a:bodyPr>
+          <a:lstStyle/>
+          <a:p>
+            <a:pPr algn="l"/>
+            <a:r>
+              <a:rPr sz="1350" b="0" i="0">
+                <a:solidFill>
+                  <a:srgbClr val="CED9E4"/>
+                </a:solidFill>
+                <a:latin typeface="Inter"/>
+              </a:rPr>
+              <a:t>Phone: +86 15858238044</a:t>
+            </a:r>
+          </a:p>
+        </p:txBody>
+      </p:sp>
+      <p:sp>
+        <p:nvSpPr>
+          <p:cNvPr id="12" name="TextBox 11"/>
+          <p:cNvSpPr txBox="1"/>
+          <p:nvPr/>
+        </p:nvSpPr>
+        <p:spPr>
+          <a:xfrm>
+            <a:off x="868680" y="4370832"/>
+            <a:ext cx="5669280" cy="365760"/>
+          </a:xfrm>
+          <a:prstGeom prst="rect">
+            <a:avLst/>
+          </a:prstGeom>
+          <a:noFill/>
+        </p:spPr>
+        <p:txBody>
+          <a:bodyPr wrap="square">
+            <a:spAutoFit/>
+          </a:bodyPr>
+          <a:lstStyle/>
+          <a:p>
+            <a:pPr algn="l"/>
+            <a:r>
+              <a:rPr sz="1350" b="0" i="0">
+                <a:solidFill>
+                  <a:srgbClr val="CED9E4"/>
+                </a:solidFill>
+                <a:latin typeface="Inter"/>
+              </a:rPr>
+              <a:t>Email: 2302372846@qq.com</a:t>
+            </a:r>
+          </a:p>
+        </p:txBody>
+      </p:sp>
+      <p:sp>
+        <p:nvSpPr>
+          <p:cNvPr id="13" name="TextBox 12"/>
+          <p:cNvSpPr txBox="1"/>
+          <p:nvPr/>
+        </p:nvSpPr>
+        <p:spPr>
+          <a:xfrm>
+            <a:off x="868680" y="4663440"/>
+            <a:ext cx="5669280" cy="365760"/>
+          </a:xfrm>
+          <a:prstGeom prst="rect">
+            <a:avLst/>
+          </a:prstGeom>
+          <a:noFill/>
+        </p:spPr>
+        <p:txBody>
+          <a:bodyPr wrap="square">
+            <a:spAutoFit/>
+          </a:bodyPr>
+          <a:lstStyle/>
+          <a:p>
+            <a:pPr algn="l"/>
+            <a:r>
+              <a:rPr sz="1350" b="0" i="0">
+                <a:solidFill>
+                  <a:srgbClr val="CED9E4"/>
+                </a:solidFill>
+                <a:latin typeface="Inter"/>
+              </a:rPr>
+              <a:t>Track: 01 · Climate-smart tea farming in Meijiawu</a:t>
+            </a:r>
+          </a:p>
+        </p:txBody>
+      </p:sp>
+      <p:sp>
+        <p:nvSpPr>
+          <p:cNvPr id="14" name="TextBox 13"/>
+          <p:cNvSpPr txBox="1"/>
+          <p:nvPr/>
+        </p:nvSpPr>
+        <p:spPr>
+          <a:xfrm>
+            <a:off x="868680" y="4956048"/>
+            <a:ext cx="5669280" cy="365760"/>
+          </a:xfrm>
+          <a:prstGeom prst="rect">
+            <a:avLst/>
+          </a:prstGeom>
+          <a:noFill/>
+        </p:spPr>
+        <p:txBody>
+          <a:bodyPr wrap="square">
+            <a:spAutoFit/>
+          </a:bodyPr>
+          <a:lstStyle/>
+          <a:p>
+            <a:pPr algn="l"/>
+            <a:r>
+              <a:rPr sz="1350" b="0" i="0">
+                <a:solidFill>
+                  <a:srgbClr val="CED9E4"/>
+                </a:solidFill>
+                <a:latin typeface="Inter"/>
+              </a:rPr>
+              <a:t>GitHub: github.com/Eric2007-sudo</a:t>
+            </a:r>
+          </a:p>
+        </p:txBody>
+      </p:sp>
+      <p:sp>
+        <p:nvSpPr>
+          <p:cNvPr id="15" name="Rectangle 14"/>
+          <p:cNvSpPr/>
+          <p:nvPr/>
+        </p:nvSpPr>
+        <p:spPr>
+          <a:xfrm>
+            <a:off x="6720840" y="1481328"/>
+            <a:ext cx="4800600" cy="3246120"/>
+          </a:xfrm>
+          <a:prstGeom prst="rect">
+            <a:avLst/>
+          </a:prstGeom>
+          <a:solidFill>
+            <a:srgbClr val="16212B"/>
+          </a:solidFill>
+          <a:ln w="9525">
+            <a:solidFill>
+              <a:srgbClr val="2B3D4D"/>
+            </a:solidFill>
+          </a:ln>
+          <a:effectLst/>
+        </p:spPr>
+        <p:style>
+          <a:lnRef idx="1">
+            <a:schemeClr val="accent1"/>
+          </a:lnRef>
+          <a:fillRef idx="3">
+            <a:schemeClr val="accent1"/>
+          </a:fillRef>
+          <a:effectRef idx="2">
+            <a:schemeClr val="accent1"/>
+          </a:effectRef>
+          <a:fontRef idx="minor">
+            <a:schemeClr val="lt1"/>
+          </a:fontRef>
+        </p:style>
+        <p:txBody>
+          <a:bodyPr rtlCol="0" anchor="ctr"/>
+          <a:lstStyle/>
+          <a:p>
+            <a:pPr algn="ctr"/>
+          </a:p>
+        </p:txBody>
+      </p:sp>
+      <p:sp>
+        <p:nvSpPr>
+          <p:cNvPr id="16" name="TextBox 15"/>
+          <p:cNvSpPr txBox="1"/>
+          <p:nvPr/>
+        </p:nvSpPr>
+        <p:spPr>
+          <a:xfrm>
+            <a:off x="6967728" y="1664208"/>
+            <a:ext cx="4389120" cy="365760"/>
+          </a:xfrm>
+          <a:prstGeom prst="rect">
+            <a:avLst/>
+          </a:prstGeom>
+          <a:noFill/>
+        </p:spPr>
+        <p:txBody>
+          <a:bodyPr wrap="square">
+            <a:spAutoFit/>
+          </a:bodyPr>
+          <a:lstStyle/>
+          <a:p>
+            <a:pPr algn="l"/>
+            <a:r>
+              <a:rPr sz="1600" b="1" i="0">
+                <a:solidFill>
+                  <a:srgbClr val="4AA8FF"/>
+                </a:solidFill>
+                <a:latin typeface="Inter"/>
+              </a:rPr>
+              <a:t>What I built</a:t>
+            </a:r>
+          </a:p>
+        </p:txBody>
+      </p:sp>
+      <p:sp>
+        <p:nvSpPr>
+          <p:cNvPr id="17" name="TextBox 16"/>
+          <p:cNvSpPr txBox="1"/>
+          <p:nvPr/>
+        </p:nvSpPr>
+        <p:spPr>
+          <a:xfrm>
+            <a:off x="6967728" y="2148840"/>
+            <a:ext cx="4343400" cy="777240"/>
+          </a:xfrm>
+          <a:prstGeom prst="rect">
+            <a:avLst/>
+          </a:prstGeom>
+          <a:noFill/>
+        </p:spPr>
+        <p:txBody>
+          <a:bodyPr wrap="square">
+            <a:spAutoFit/>
+          </a:bodyPr>
+          <a:lstStyle/>
+          <a:p>
+            <a:pPr algn="l"/>
+            <a:r>
+              <a:rPr sz="1250" b="0" i="0">
+                <a:solidFill>
+                  <a:srgbClr val="CED9E4"/>
+                </a:solidFill>
+                <a:latin typeface="Inter"/>
+              </a:rPr>
+              <a:t>• Data: ERA5 + MET Norway, Sentinel-2, 30 m DEM downscaling</a:t>
+            </a:r>
+          </a:p>
+        </p:txBody>
+      </p:sp>
+      <p:sp>
+        <p:nvSpPr>
+          <p:cNvPr id="18" name="TextBox 17"/>
+          <p:cNvSpPr txBox="1"/>
+          <p:nvPr/>
+        </p:nvSpPr>
+        <p:spPr>
+          <a:xfrm>
+            <a:off x="6967728" y="2971800"/>
+            <a:ext cx="4343400" cy="777240"/>
+          </a:xfrm>
+          <a:prstGeom prst="rect">
+            <a:avLst/>
+          </a:prstGeom>
+          <a:noFill/>
+        </p:spPr>
+        <p:txBody>
+          <a:bodyPr wrap="square">
+            <a:spAutoFit/>
+          </a:bodyPr>
+          <a:lstStyle/>
+          <a:p>
+            <a:pPr algn="l"/>
+            <a:r>
+              <a:rPr sz="1250" b="0" i="0">
+                <a:solidFill>
+                  <a:srgbClr val="CED9E4"/>
+                </a:solidFill>
+                <a:latin typeface="Inter"/>
+              </a:rPr>
+              <a:t>• Model: numpy GBDT compound risk; frozen eval set; picking-date MAE 1.8 d</a:t>
+            </a:r>
+          </a:p>
+        </p:txBody>
+      </p:sp>
+      <p:sp>
+        <p:nvSpPr>
+          <p:cNvPr id="19" name="TextBox 18"/>
+          <p:cNvSpPr txBox="1"/>
+          <p:nvPr/>
+        </p:nvSpPr>
+        <p:spPr>
+          <a:xfrm>
+            <a:off x="6967728" y="3794760"/>
+            <a:ext cx="4343400" cy="777240"/>
+          </a:xfrm>
+          <a:prstGeom prst="rect">
+            <a:avLst/>
+          </a:prstGeom>
+          <a:noFill/>
+        </p:spPr>
+        <p:txBody>
+          <a:bodyPr wrap="square">
+            <a:spAutoFit/>
+          </a:bodyPr>
+          <a:lstStyle/>
+          <a:p>
+            <a:pPr algn="l"/>
+            <a:r>
+              <a:rPr sz="1250" b="0" i="0">
+                <a:solidFill>
+                  <a:srgbClr val="CED9E4"/>
+                </a:solidFill>
+                <a:latin typeface="Inter"/>
+              </a:rPr>
+              <a:t>• Product: live demo, terrain risk map, grounded Q&amp;A with the 1+5 gate, deployment</a:t>
+            </a:r>
+          </a:p>
+        </p:txBody>
+      </p:sp>
+      <p:sp>
+        <p:nvSpPr>
+          <p:cNvPr id="20" name="TextBox 19"/>
+          <p:cNvSpPr txBox="1"/>
+          <p:nvPr/>
+        </p:nvSpPr>
+        <p:spPr>
+          <a:xfrm>
+            <a:off x="868680" y="5440680"/>
+            <a:ext cx="10607040" cy="457200"/>
+          </a:xfrm>
+          <a:prstGeom prst="rect">
+            <a:avLst/>
+          </a:prstGeom>
+          <a:noFill/>
+        </p:spPr>
+        <p:txBody>
+          <a:bodyPr wrap="square">
+            <a:spAutoFit/>
+          </a:bodyPr>
+          <a:lstStyle/>
+          <a:p>
+            <a:pPr algn="l"/>
+            <a:r>
+              <a:rPr sz="1800" b="0" i="1">
+                <a:solidFill>
+                  <a:srgbClr val="E8EEF3"/>
+                </a:solidFill>
+                <a:latin typeface="Inter"/>
+              </a:rPr>
+              <a:t>Turning climate data into an action a tea farmer can take today.</a:t>
+            </a:r>
+          </a:p>
+        </p:txBody>
+      </p:sp>
+      <p:sp>
+        <p:nvSpPr>
+          <p:cNvPr id="21" name="TextBox 20"/>
+          <p:cNvSpPr txBox="1"/>
+          <p:nvPr/>
+        </p:nvSpPr>
+        <p:spPr>
+          <a:xfrm>
+            <a:off x="868680" y="5989320"/>
+            <a:ext cx="10607040" cy="365760"/>
+          </a:xfrm>
+          <a:prstGeom prst="rect">
+            <a:avLst/>
+          </a:prstGeom>
+          <a:noFill/>
+        </p:spPr>
+        <p:txBody>
+          <a:bodyPr wrap="square">
+            <a:spAutoFit/>
+          </a:bodyPr>
+          <a:lstStyle/>
+          <a:p>
+            <a:pPr algn="l"/>
+            <a:r>
+              <a:rPr sz="1050" b="0" i="0">
+                <a:solidFill>
+                  <a:srgbClr val="9FB4C6"/>
+                </a:solidFill>
+                <a:latin typeface="Inter"/>
+              </a:rPr>
+              <a:t>Demo: teawindow.onrender.com | Repo: github.com/Eric2007-sudo/TeaWindow | Stage: prototype / demo available</a:t>
+            </a:r>
+          </a:p>
+        </p:txBody>
+      </p:sp>
     </p:spTree>
   </p:cSld>
   <p:clrMapOvr>
@@ -22256,700 +22961,30 @@
         <p:nvPr/>
       </p:nvGrpSpPr>
       <p:grpSpPr/>
-      <p:sp>
-        <p:nvSpPr>
-          <p:cNvPr id="2" name="Rectangle 1"/>
-          <p:cNvSpPr/>
+      <p:pic>
+        <p:nvPicPr>
+          <p:cNvPr id="2" name="Picture 1" descr="30_architecture_1plus5_EN.png"/>
+          <p:cNvPicPr>
+            <a:picLocks noChangeAspect="1"/>
+          </p:cNvPicPr>
           <p:nvPr/>
-        </p:nvSpPr>
+        </p:nvPicPr>
+        <p:blipFill>
+          <a:blip r:embed="rId2"/>
+          <a:stretch>
+            <a:fillRect/>
+          </a:stretch>
+        </p:blipFill>
         <p:spPr>
           <a:xfrm>
             <a:off x="0" y="0"/>
-            <a:ext cx="12179808" cy="6858000"/>
+            <a:ext cx="12179300" cy="6858000"/>
           </a:xfrm>
           <a:prstGeom prst="rect">
             <a:avLst/>
           </a:prstGeom>
-          <a:solidFill>
-            <a:srgbClr val="0F1720"/>
-          </a:solidFill>
-          <a:ln>
-            <a:noFill/>
-          </a:ln>
-          <a:effectLst/>
-        </p:spPr>
-        <p:style>
-          <a:lnRef idx="1">
-            <a:schemeClr val="accent1"/>
-          </a:lnRef>
-          <a:fillRef idx="3">
-            <a:schemeClr val="accent1"/>
-          </a:fillRef>
-          <a:effectRef idx="2">
-            <a:schemeClr val="accent1"/>
-          </a:effectRef>
-          <a:fontRef idx="minor">
-            <a:schemeClr val="lt1"/>
-          </a:fontRef>
-        </p:style>
-        <p:txBody>
-          <a:bodyPr rtlCol="0" anchor="ctr"/>
-          <a:lstStyle/>
-          <a:p>
-            <a:pPr algn="ctr"/>
-          </a:p>
-        </p:txBody>
-      </p:sp>
-      <p:sp>
-        <p:nvSpPr>
-          <p:cNvPr id="3" name="Rectangle 2"/>
-          <p:cNvSpPr/>
-          <p:nvPr/>
-        </p:nvSpPr>
-        <p:spPr>
-          <a:xfrm>
-            <a:off x="640080" y="658368"/>
-            <a:ext cx="64008" cy="777240"/>
-          </a:xfrm>
-          <a:prstGeom prst="rect">
-            <a:avLst/>
-          </a:prstGeom>
-          <a:solidFill>
-            <a:srgbClr val="4AA8FF"/>
-          </a:solidFill>
-          <a:ln>
-            <a:noFill/>
-          </a:ln>
-          <a:effectLst/>
-        </p:spPr>
-        <p:style>
-          <a:lnRef idx="1">
-            <a:schemeClr val="accent1"/>
-          </a:lnRef>
-          <a:fillRef idx="3">
-            <a:schemeClr val="accent1"/>
-          </a:fillRef>
-          <a:effectRef idx="2">
-            <a:schemeClr val="accent1"/>
-          </a:effectRef>
-          <a:fontRef idx="minor">
-            <a:schemeClr val="lt1"/>
-          </a:fontRef>
-        </p:style>
-        <p:txBody>
-          <a:bodyPr rtlCol="0" anchor="ctr"/>
-          <a:lstStyle/>
-          <a:p>
-            <a:pPr algn="ctr"/>
-          </a:p>
-        </p:txBody>
-      </p:sp>
-      <p:sp>
-        <p:nvSpPr>
-          <p:cNvPr id="4" name="TextBox 3"/>
-          <p:cNvSpPr txBox="1"/>
-          <p:nvPr/>
-        </p:nvSpPr>
-        <p:spPr>
-          <a:xfrm>
-            <a:off x="868680" y="621792"/>
-            <a:ext cx="8229600" cy="640080"/>
-          </a:xfrm>
-          <a:prstGeom prst="rect">
-            <a:avLst/>
-          </a:prstGeom>
-          <a:noFill/>
-        </p:spPr>
-        <p:txBody>
-          <a:bodyPr wrap="square">
-            <a:spAutoFit/>
-          </a:bodyPr>
-          <a:lstStyle/>
-          <a:p>
-            <a:pPr algn="l"/>
-            <a:r>
-              <a:rPr sz="3000" b="1" i="0">
-                <a:solidFill>
-                  <a:srgbClr val="E8EEF3"/>
-                </a:solidFill>
-                <a:latin typeface="Montserrat"/>
-              </a:rPr>
-              <a:t>Team &amp; background</a:t>
-            </a:r>
-          </a:p>
-        </p:txBody>
-      </p:sp>
-      <p:sp>
-        <p:nvSpPr>
-          <p:cNvPr id="5" name="TextBox 4"/>
-          <p:cNvSpPr txBox="1"/>
-          <p:nvPr/>
-        </p:nvSpPr>
-        <p:spPr>
-          <a:xfrm>
-            <a:off x="868680" y="1481328"/>
-            <a:ext cx="5486400" cy="731520"/>
-          </a:xfrm>
-          <a:prstGeom prst="rect">
-            <a:avLst/>
-          </a:prstGeom>
-          <a:noFill/>
-        </p:spPr>
-        <p:txBody>
-          <a:bodyPr wrap="square">
-            <a:spAutoFit/>
-          </a:bodyPr>
-          <a:lstStyle/>
-          <a:p>
-            <a:pPr algn="l"/>
-            <a:r>
-              <a:rPr sz="4000" b="1" i="0">
-                <a:solidFill>
-                  <a:srgbClr val="E8EEF3"/>
-                </a:solidFill>
-                <a:latin typeface="Montserrat"/>
-              </a:rPr>
-              <a:t>Ye Zixuan</a:t>
-            </a:r>
-          </a:p>
-        </p:txBody>
-      </p:sp>
-      <p:sp>
-        <p:nvSpPr>
-          <p:cNvPr id="6" name="TextBox 5"/>
-          <p:cNvSpPr txBox="1"/>
-          <p:nvPr/>
-        </p:nvSpPr>
-        <p:spPr>
-          <a:xfrm>
-            <a:off x="868680" y="2148840"/>
-            <a:ext cx="5486400" cy="365760"/>
-          </a:xfrm>
-          <a:prstGeom prst="rect">
-            <a:avLst/>
-          </a:prstGeom>
-          <a:noFill/>
-        </p:spPr>
-        <p:txBody>
-          <a:bodyPr wrap="square">
-            <a:spAutoFit/>
-          </a:bodyPr>
-          <a:lstStyle/>
-          <a:p>
-            <a:pPr algn="l"/>
-            <a:r>
-              <a:rPr sz="1800" b="0" i="0">
-                <a:solidFill>
-                  <a:srgbClr val="9FB4C6"/>
-                </a:solidFill>
-                <a:latin typeface="Montserrat"/>
-              </a:rPr>
-              <a:t>叶子玄</a:t>
-            </a:r>
-          </a:p>
-        </p:txBody>
-      </p:sp>
-      <p:sp>
-        <p:nvSpPr>
-          <p:cNvPr id="7" name="TextBox 6"/>
-          <p:cNvSpPr txBox="1"/>
-          <p:nvPr/>
-        </p:nvSpPr>
-        <p:spPr>
-          <a:xfrm>
-            <a:off x="868680" y="2606040"/>
-            <a:ext cx="5669280" cy="457200"/>
-          </a:xfrm>
-          <a:prstGeom prst="rect">
-            <a:avLst/>
-          </a:prstGeom>
-          <a:noFill/>
-        </p:spPr>
-        <p:txBody>
-          <a:bodyPr wrap="square">
-            <a:spAutoFit/>
-          </a:bodyPr>
-          <a:lstStyle/>
-          <a:p>
-            <a:pPr algn="l"/>
-            <a:r>
-              <a:rPr sz="1600" b="0" i="0">
-                <a:solidFill>
-                  <a:srgbClr val="CED9E4"/>
-                </a:solidFill>
-                <a:latin typeface="Inter"/>
-              </a:rPr>
-              <a:t>Zhejiang University · Computer Science and Technology (BSc, Year 2)</a:t>
-            </a:r>
-          </a:p>
-        </p:txBody>
-      </p:sp>
-      <p:sp>
-        <p:nvSpPr>
-          <p:cNvPr id="8" name="TextBox 7"/>
-          <p:cNvSpPr txBox="1"/>
-          <p:nvPr/>
-        </p:nvSpPr>
-        <p:spPr>
-          <a:xfrm>
-            <a:off x="868680" y="3200400"/>
-            <a:ext cx="5669280" cy="365760"/>
-          </a:xfrm>
-          <a:prstGeom prst="rect">
-            <a:avLst/>
-          </a:prstGeom>
-          <a:noFill/>
-        </p:spPr>
-        <p:txBody>
-          <a:bodyPr wrap="square">
-            <a:spAutoFit/>
-          </a:bodyPr>
-          <a:lstStyle/>
-          <a:p>
-            <a:pPr algn="l"/>
-            <a:r>
-              <a:rPr sz="1350" b="0" i="0">
-                <a:solidFill>
-                  <a:srgbClr val="CED9E4"/>
-                </a:solidFill>
-                <a:latin typeface="Inter"/>
-              </a:rPr>
-              <a:t>Role: project lead · algorithms &amp; full-stack</a:t>
-            </a:r>
-          </a:p>
-        </p:txBody>
-      </p:sp>
-      <p:sp>
-        <p:nvSpPr>
-          <p:cNvPr id="9" name="TextBox 8"/>
-          <p:cNvSpPr txBox="1"/>
-          <p:nvPr/>
-        </p:nvSpPr>
-        <p:spPr>
-          <a:xfrm>
-            <a:off x="868680" y="3538728"/>
-            <a:ext cx="5669280" cy="365760"/>
-          </a:xfrm>
-          <a:prstGeom prst="rect">
-            <a:avLst/>
-          </a:prstGeom>
-          <a:noFill/>
-        </p:spPr>
-        <p:txBody>
-          <a:bodyPr wrap="square">
-            <a:spAutoFit/>
-          </a:bodyPr>
-          <a:lstStyle/>
-          <a:p>
-            <a:pPr algn="l"/>
-            <a:r>
-              <a:rPr sz="1350" b="0" i="0">
-                <a:solidFill>
-                  <a:srgbClr val="CED9E4"/>
-                </a:solidFill>
-                <a:latin typeface="Inter"/>
-              </a:rPr>
-              <a:t>Team: solo (1 person) · age 19</a:t>
-            </a:r>
-          </a:p>
-        </p:txBody>
-      </p:sp>
-      <p:sp>
-        <p:nvSpPr>
-          <p:cNvPr id="10" name="TextBox 9"/>
-          <p:cNvSpPr txBox="1"/>
-          <p:nvPr/>
-        </p:nvSpPr>
-        <p:spPr>
-          <a:xfrm>
-            <a:off x="868680" y="3877056"/>
-            <a:ext cx="5669280" cy="365760"/>
-          </a:xfrm>
-          <a:prstGeom prst="rect">
-            <a:avLst/>
-          </a:prstGeom>
-          <a:noFill/>
-        </p:spPr>
-        <p:txBody>
-          <a:bodyPr wrap="square">
-            <a:spAutoFit/>
-          </a:bodyPr>
-          <a:lstStyle/>
-          <a:p>
-            <a:pPr algn="l"/>
-            <a:r>
-              <a:rPr sz="1350" b="0" i="0">
-                <a:solidFill>
-                  <a:srgbClr val="CED9E4"/>
-                </a:solidFill>
-                <a:latin typeface="Inter"/>
-              </a:rPr>
-              <a:t>Location: Hangzhou, China</a:t>
-            </a:r>
-          </a:p>
-        </p:txBody>
-      </p:sp>
-      <p:sp>
-        <p:nvSpPr>
-          <p:cNvPr id="11" name="TextBox 10"/>
-          <p:cNvSpPr txBox="1"/>
-          <p:nvPr/>
-        </p:nvSpPr>
-        <p:spPr>
-          <a:xfrm>
-            <a:off x="868680" y="4215384"/>
-            <a:ext cx="5669280" cy="365760"/>
-          </a:xfrm>
-          <a:prstGeom prst="rect">
-            <a:avLst/>
-          </a:prstGeom>
-          <a:noFill/>
-        </p:spPr>
-        <p:txBody>
-          <a:bodyPr wrap="square">
-            <a:spAutoFit/>
-          </a:bodyPr>
-          <a:lstStyle/>
-          <a:p>
-            <a:pPr algn="l"/>
-            <a:r>
-              <a:rPr sz="1350" b="0" i="0">
-                <a:solidFill>
-                  <a:srgbClr val="CED9E4"/>
-                </a:solidFill>
-                <a:latin typeface="Inter"/>
-              </a:rPr>
-              <a:t>Phone: +86 15858238044</a:t>
-            </a:r>
-          </a:p>
-        </p:txBody>
-      </p:sp>
-      <p:sp>
-        <p:nvSpPr>
-          <p:cNvPr id="12" name="TextBox 11"/>
-          <p:cNvSpPr txBox="1"/>
-          <p:nvPr/>
-        </p:nvSpPr>
-        <p:spPr>
-          <a:xfrm>
-            <a:off x="868680" y="4553712"/>
-            <a:ext cx="5669280" cy="365760"/>
-          </a:xfrm>
-          <a:prstGeom prst="rect">
-            <a:avLst/>
-          </a:prstGeom>
-          <a:noFill/>
-        </p:spPr>
-        <p:txBody>
-          <a:bodyPr wrap="square">
-            <a:spAutoFit/>
-          </a:bodyPr>
-          <a:lstStyle/>
-          <a:p>
-            <a:pPr algn="l"/>
-            <a:r>
-              <a:rPr sz="1350" b="0" i="0">
-                <a:solidFill>
-                  <a:srgbClr val="CED9E4"/>
-                </a:solidFill>
-                <a:latin typeface="Inter"/>
-              </a:rPr>
-              <a:t>Email: 2302372846@qq.com</a:t>
-            </a:r>
-          </a:p>
-        </p:txBody>
-      </p:sp>
-      <p:sp>
-        <p:nvSpPr>
-          <p:cNvPr id="13" name="TextBox 12"/>
-          <p:cNvSpPr txBox="1"/>
-          <p:nvPr/>
-        </p:nvSpPr>
-        <p:spPr>
-          <a:xfrm>
-            <a:off x="868680" y="4892040"/>
-            <a:ext cx="5669280" cy="365760"/>
-          </a:xfrm>
-          <a:prstGeom prst="rect">
-            <a:avLst/>
-          </a:prstGeom>
-          <a:noFill/>
-        </p:spPr>
-        <p:txBody>
-          <a:bodyPr wrap="square">
-            <a:spAutoFit/>
-          </a:bodyPr>
-          <a:lstStyle/>
-          <a:p>
-            <a:pPr algn="l"/>
-            <a:r>
-              <a:rPr sz="1350" b="0" i="0">
-                <a:solidFill>
-                  <a:srgbClr val="CED9E4"/>
-                </a:solidFill>
-                <a:latin typeface="Inter"/>
-              </a:rPr>
-              <a:t>Track: 01 · Climate-smart tea farming in Meijiawu</a:t>
-            </a:r>
-          </a:p>
-        </p:txBody>
-      </p:sp>
-      <p:sp>
-        <p:nvSpPr>
-          <p:cNvPr id="14" name="Rectangle 13"/>
-          <p:cNvSpPr/>
-          <p:nvPr/>
-        </p:nvSpPr>
-        <p:spPr>
-          <a:xfrm>
-            <a:off x="6720840" y="1481328"/>
-            <a:ext cx="4800600" cy="3246120"/>
-          </a:xfrm>
-          <a:prstGeom prst="rect">
-            <a:avLst/>
-          </a:prstGeom>
-          <a:solidFill>
-            <a:srgbClr val="16212B"/>
-          </a:solidFill>
-          <a:ln w="9525">
-            <a:solidFill>
-              <a:srgbClr val="2B3D4D"/>
-            </a:solidFill>
-          </a:ln>
-          <a:effectLst/>
-        </p:spPr>
-        <p:style>
-          <a:lnRef idx="1">
-            <a:schemeClr val="accent1"/>
-          </a:lnRef>
-          <a:fillRef idx="3">
-            <a:schemeClr val="accent1"/>
-          </a:fillRef>
-          <a:effectRef idx="2">
-            <a:schemeClr val="accent1"/>
-          </a:effectRef>
-          <a:fontRef idx="minor">
-            <a:schemeClr val="lt1"/>
-          </a:fontRef>
-        </p:style>
-        <p:txBody>
-          <a:bodyPr rtlCol="0" anchor="ctr"/>
-          <a:lstStyle/>
-          <a:p>
-            <a:pPr algn="ctr"/>
-          </a:p>
-        </p:txBody>
-      </p:sp>
-      <p:sp>
-        <p:nvSpPr>
-          <p:cNvPr id="15" name="TextBox 14"/>
-          <p:cNvSpPr txBox="1"/>
-          <p:nvPr/>
-        </p:nvSpPr>
-        <p:spPr>
-          <a:xfrm>
-            <a:off x="6967728" y="1664208"/>
-            <a:ext cx="4389120" cy="365760"/>
-          </a:xfrm>
-          <a:prstGeom prst="rect">
-            <a:avLst/>
-          </a:prstGeom>
-          <a:noFill/>
-        </p:spPr>
-        <p:txBody>
-          <a:bodyPr wrap="square">
-            <a:spAutoFit/>
-          </a:bodyPr>
-          <a:lstStyle/>
-          <a:p>
-            <a:pPr algn="l"/>
-            <a:r>
-              <a:rPr sz="1600" b="1" i="0">
-                <a:solidFill>
-                  <a:srgbClr val="4AA8FF"/>
-                </a:solidFill>
-                <a:latin typeface="Inter"/>
-              </a:rPr>
-              <a:t>What I built</a:t>
-            </a:r>
-          </a:p>
-        </p:txBody>
-      </p:sp>
-      <p:sp>
-        <p:nvSpPr>
-          <p:cNvPr id="16" name="TextBox 15"/>
-          <p:cNvSpPr txBox="1"/>
-          <p:nvPr/>
-        </p:nvSpPr>
-        <p:spPr>
-          <a:xfrm>
-            <a:off x="6967728" y="2148840"/>
-            <a:ext cx="4343400" cy="777240"/>
-          </a:xfrm>
-          <a:prstGeom prst="rect">
-            <a:avLst/>
-          </a:prstGeom>
-          <a:noFill/>
-        </p:spPr>
-        <p:txBody>
-          <a:bodyPr wrap="square">
-            <a:spAutoFit/>
-          </a:bodyPr>
-          <a:lstStyle/>
-          <a:p>
-            <a:pPr algn="l"/>
-            <a:r>
-              <a:rPr sz="1250" b="0" i="0">
-                <a:solidFill>
-                  <a:srgbClr val="CED9E4"/>
-                </a:solidFill>
-                <a:latin typeface="Inter"/>
-              </a:rPr>
-              <a:t>• Data: ERA5 + MET Norway, Sentinel-2, 30 m DEM downscaling</a:t>
-            </a:r>
-          </a:p>
-        </p:txBody>
-      </p:sp>
-      <p:sp>
-        <p:nvSpPr>
-          <p:cNvPr id="17" name="TextBox 16"/>
-          <p:cNvSpPr txBox="1"/>
-          <p:nvPr/>
-        </p:nvSpPr>
-        <p:spPr>
-          <a:xfrm>
-            <a:off x="6967728" y="2971800"/>
-            <a:ext cx="4343400" cy="777240"/>
-          </a:xfrm>
-          <a:prstGeom prst="rect">
-            <a:avLst/>
-          </a:prstGeom>
-          <a:noFill/>
-        </p:spPr>
-        <p:txBody>
-          <a:bodyPr wrap="square">
-            <a:spAutoFit/>
-          </a:bodyPr>
-          <a:lstStyle/>
-          <a:p>
-            <a:pPr algn="l"/>
-            <a:r>
-              <a:rPr sz="1250" b="0" i="0">
-                <a:solidFill>
-                  <a:srgbClr val="CED9E4"/>
-                </a:solidFill>
-                <a:latin typeface="Inter"/>
-              </a:rPr>
-              <a:t>• Model: numpy GBDT compound risk; frozen eval set; picking-date MAE 1.8 d</a:t>
-            </a:r>
-          </a:p>
-        </p:txBody>
-      </p:sp>
-      <p:sp>
-        <p:nvSpPr>
-          <p:cNvPr id="18" name="TextBox 17"/>
-          <p:cNvSpPr txBox="1"/>
-          <p:nvPr/>
-        </p:nvSpPr>
-        <p:spPr>
-          <a:xfrm>
-            <a:off x="6967728" y="3794760"/>
-            <a:ext cx="4343400" cy="777240"/>
-          </a:xfrm>
-          <a:prstGeom prst="rect">
-            <a:avLst/>
-          </a:prstGeom>
-          <a:noFill/>
-        </p:spPr>
-        <p:txBody>
-          <a:bodyPr wrap="square">
-            <a:spAutoFit/>
-          </a:bodyPr>
-          <a:lstStyle/>
-          <a:p>
-            <a:pPr algn="l"/>
-            <a:r>
-              <a:rPr sz="1250" b="0" i="0">
-                <a:solidFill>
-                  <a:srgbClr val="CED9E4"/>
-                </a:solidFill>
-                <a:latin typeface="Inter"/>
-              </a:rPr>
-              <a:t>• Product: live demo, terrain risk map, grounded Q&amp;A with the 1+5 gate, deployment</a:t>
-            </a:r>
-          </a:p>
-        </p:txBody>
-      </p:sp>
-      <p:sp>
-        <p:nvSpPr>
-          <p:cNvPr id="19" name="TextBox 18"/>
-          <p:cNvSpPr txBox="1"/>
-          <p:nvPr/>
-        </p:nvSpPr>
-        <p:spPr>
-          <a:xfrm>
-            <a:off x="868680" y="5257800"/>
-            <a:ext cx="10607040" cy="457200"/>
-          </a:xfrm>
-          <a:prstGeom prst="rect">
-            <a:avLst/>
-          </a:prstGeom>
-          <a:noFill/>
-        </p:spPr>
-        <p:txBody>
-          <a:bodyPr wrap="square">
-            <a:spAutoFit/>
-          </a:bodyPr>
-          <a:lstStyle/>
-          <a:p>
-            <a:pPr algn="l"/>
-            <a:r>
-              <a:rPr sz="1800" b="0" i="1">
-                <a:solidFill>
-                  <a:srgbClr val="E8EEF3"/>
-                </a:solidFill>
-                <a:latin typeface="Inter"/>
-              </a:rPr>
-              <a:t>Turning climate data into an action a tea farmer can take today.</a:t>
-            </a:r>
-          </a:p>
-        </p:txBody>
-      </p:sp>
-      <p:sp>
-        <p:nvSpPr>
-          <p:cNvPr id="20" name="TextBox 19"/>
-          <p:cNvSpPr txBox="1"/>
-          <p:nvPr/>
-        </p:nvSpPr>
-        <p:spPr>
-          <a:xfrm>
-            <a:off x="868680" y="5989320"/>
-            <a:ext cx="10607040" cy="365760"/>
-          </a:xfrm>
-          <a:prstGeom prst="rect">
-            <a:avLst/>
-          </a:prstGeom>
-          <a:noFill/>
-        </p:spPr>
-        <p:txBody>
-          <a:bodyPr wrap="square">
-            <a:spAutoFit/>
-          </a:bodyPr>
-          <a:lstStyle/>
-          <a:p>
-            <a:pPr algn="l"/>
-            <a:r>
-              <a:rPr sz="1050" b="0" i="0">
-                <a:solidFill>
-                  <a:srgbClr val="9FB4C6"/>
-                </a:solidFill>
-                <a:latin typeface="Inter"/>
-              </a:rPr>
-              <a:t>Demo: teawindow.onrender.com | Repo: github.com/Eric2007-sudo/TeaWindow | Stage: prototype / demo available</a:t>
-            </a:r>
-          </a:p>
-        </p:txBody>
-      </p:sp>
+        </p:spPr>
+      </p:pic>
     </p:spTree>
   </p:cSld>
   <p:clrMapOvr>

</xml_diff>

<commit_message>
deck: add headshot to team slide; clean 14p rebuild
</commit_message>
<xml_diff>
--- a/submit/01_TeaWindow_Pitch_EN_14p.pptx
+++ b/submit/01_TeaWindow_Pitch_EN_14p.pptx
@@ -22302,9 +22302,38 @@
           </a:p>
         </p:txBody>
       </p:sp>
-      <p:sp>
-        <p:nvSpPr>
-          <p:cNvPr id="4" name="TextBox 3"/>
+      <p:pic>
+        <p:nvPicPr>
+          <p:cNvPr id="4" name="Picture 3" descr="photo.jpg"/>
+          <p:cNvPicPr>
+            <a:picLocks noChangeAspect="1"/>
+          </p:cNvPicPr>
+          <p:nvPr/>
+        </p:nvPicPr>
+        <p:blipFill>
+          <a:blip r:embed="rId2"/>
+          <a:stretch>
+            <a:fillRect/>
+          </a:stretch>
+        </p:blipFill>
+        <p:spPr>
+          <a:xfrm>
+            <a:off x="868680" y="1463040"/>
+            <a:ext cx="1601093" cy="2240280"/>
+          </a:xfrm>
+          <a:prstGeom prst="rect">
+            <a:avLst/>
+          </a:prstGeom>
+          <a:ln w="15875">
+            <a:solidFill>
+              <a:srgbClr val="4AA8FF"/>
+            </a:solidFill>
+          </a:ln>
+        </p:spPr>
+      </p:pic>
+      <p:sp>
+        <p:nvSpPr>
+          <p:cNvPr id="5" name="TextBox 4"/>
           <p:cNvSpPr txBox="1"/>
           <p:nvPr/>
         </p:nvSpPr>
@@ -22339,14 +22368,14 @@
       </p:sp>
       <p:sp>
         <p:nvSpPr>
-          <p:cNvPr id="5" name="TextBox 4"/>
+          <p:cNvPr id="6" name="TextBox 5"/>
           <p:cNvSpPr txBox="1"/>
           <p:nvPr/>
         </p:nvSpPr>
         <p:spPr>
           <a:xfrm>
-            <a:off x="868680" y="1481328"/>
-            <a:ext cx="5486400" cy="731520"/>
+            <a:off x="2789813" y="1481328"/>
+            <a:ext cx="5120640" cy="731520"/>
           </a:xfrm>
           <a:prstGeom prst="rect">
             <a:avLst/>
@@ -22361,7 +22390,7 @@
           <a:p>
             <a:pPr algn="l"/>
             <a:r>
-              <a:rPr sz="4000" b="1" i="0">
+              <a:rPr sz="3800" b="1" i="0">
                 <a:solidFill>
                   <a:srgbClr val="E8EEF3"/>
                 </a:solidFill>
@@ -22374,14 +22403,14 @@
       </p:sp>
       <p:sp>
         <p:nvSpPr>
-          <p:cNvPr id="6" name="TextBox 5"/>
+          <p:cNvPr id="7" name="TextBox 6"/>
           <p:cNvSpPr txBox="1"/>
           <p:nvPr/>
         </p:nvSpPr>
         <p:spPr>
           <a:xfrm>
-            <a:off x="868680" y="2148840"/>
-            <a:ext cx="5486400" cy="365760"/>
+            <a:off x="2789813" y="2121408"/>
+            <a:ext cx="5120640" cy="365760"/>
           </a:xfrm>
           <a:prstGeom prst="rect">
             <a:avLst/>
@@ -22396,7 +22425,7 @@
           <a:p>
             <a:pPr algn="l"/>
             <a:r>
-              <a:rPr sz="1800" b="0" i="0">
+              <a:rPr sz="1700" b="0" i="0">
                 <a:solidFill>
                   <a:srgbClr val="9FB4C6"/>
                 </a:solidFill>
@@ -22409,14 +22438,14 @@
       </p:sp>
       <p:sp>
         <p:nvSpPr>
-          <p:cNvPr id="7" name="TextBox 6"/>
+          <p:cNvPr id="8" name="TextBox 7"/>
           <p:cNvSpPr txBox="1"/>
           <p:nvPr/>
         </p:nvSpPr>
         <p:spPr>
           <a:xfrm>
-            <a:off x="868680" y="2606040"/>
-            <a:ext cx="5669280" cy="457200"/>
+            <a:off x="2789813" y="2560320"/>
+            <a:ext cx="3794760" cy="731520"/>
           </a:xfrm>
           <a:prstGeom prst="rect">
             <a:avLst/>
@@ -22431,7 +22460,7 @@
           <a:p>
             <a:pPr algn="l"/>
             <a:r>
-              <a:rPr sz="1600" b="0" i="0">
+              <a:rPr sz="1350" b="0" i="0">
                 <a:solidFill>
                   <a:srgbClr val="CED9E4"/>
                 </a:solidFill>
@@ -22444,14 +22473,14 @@
       </p:sp>
       <p:sp>
         <p:nvSpPr>
-          <p:cNvPr id="8" name="TextBox 7"/>
+          <p:cNvPr id="9" name="TextBox 8"/>
           <p:cNvSpPr txBox="1"/>
           <p:nvPr/>
         </p:nvSpPr>
         <p:spPr>
           <a:xfrm>
-            <a:off x="868680" y="3200400"/>
-            <a:ext cx="5669280" cy="365760"/>
+            <a:off x="2789813" y="3218688"/>
+            <a:ext cx="3749039" cy="502920"/>
           </a:xfrm>
           <a:prstGeom prst="rect">
             <a:avLst/>
@@ -22466,7 +22495,7 @@
           <a:p>
             <a:pPr algn="l"/>
             <a:r>
-              <a:rPr sz="1350" b="0" i="0">
+              <a:rPr sz="1150" b="0" i="0">
                 <a:solidFill>
                   <a:srgbClr val="CED9E4"/>
                 </a:solidFill>
@@ -22479,14 +22508,14 @@
       </p:sp>
       <p:sp>
         <p:nvSpPr>
-          <p:cNvPr id="9" name="TextBox 8"/>
+          <p:cNvPr id="10" name="TextBox 9"/>
           <p:cNvSpPr txBox="1"/>
           <p:nvPr/>
         </p:nvSpPr>
         <p:spPr>
           <a:xfrm>
-            <a:off x="868680" y="3493008"/>
-            <a:ext cx="5669280" cy="365760"/>
+            <a:off x="2789813" y="3511296"/>
+            <a:ext cx="3749039" cy="502920"/>
           </a:xfrm>
           <a:prstGeom prst="rect">
             <a:avLst/>
@@ -22501,7 +22530,7 @@
           <a:p>
             <a:pPr algn="l"/>
             <a:r>
-              <a:rPr sz="1350" b="0" i="0">
+              <a:rPr sz="1150" b="0" i="0">
                 <a:solidFill>
                   <a:srgbClr val="CED9E4"/>
                 </a:solidFill>
@@ -22514,14 +22543,14 @@
       </p:sp>
       <p:sp>
         <p:nvSpPr>
-          <p:cNvPr id="10" name="TextBox 9"/>
+          <p:cNvPr id="11" name="TextBox 10"/>
           <p:cNvSpPr txBox="1"/>
           <p:nvPr/>
         </p:nvSpPr>
         <p:spPr>
           <a:xfrm>
-            <a:off x="868680" y="3785615"/>
-            <a:ext cx="5669280" cy="365760"/>
+            <a:off x="2789813" y="3803904"/>
+            <a:ext cx="3749039" cy="502920"/>
           </a:xfrm>
           <a:prstGeom prst="rect">
             <a:avLst/>
@@ -22536,7 +22565,7 @@
           <a:p>
             <a:pPr algn="l"/>
             <a:r>
-              <a:rPr sz="1350" b="0" i="0">
+              <a:rPr sz="1150" b="0" i="0">
                 <a:solidFill>
                   <a:srgbClr val="CED9E4"/>
                 </a:solidFill>
@@ -22549,14 +22578,14 @@
       </p:sp>
       <p:sp>
         <p:nvSpPr>
-          <p:cNvPr id="11" name="TextBox 10"/>
+          <p:cNvPr id="12" name="TextBox 11"/>
           <p:cNvSpPr txBox="1"/>
           <p:nvPr/>
         </p:nvSpPr>
         <p:spPr>
           <a:xfrm>
-            <a:off x="868680" y="4078224"/>
-            <a:ext cx="5669280" cy="365760"/>
+            <a:off x="2789813" y="4096512"/>
+            <a:ext cx="3749039" cy="502920"/>
           </a:xfrm>
           <a:prstGeom prst="rect">
             <a:avLst/>
@@ -22571,7 +22600,7 @@
           <a:p>
             <a:pPr algn="l"/>
             <a:r>
-              <a:rPr sz="1350" b="0" i="0">
+              <a:rPr sz="1150" b="0" i="0">
                 <a:solidFill>
                   <a:srgbClr val="CED9E4"/>
                 </a:solidFill>
@@ -22584,14 +22613,14 @@
       </p:sp>
       <p:sp>
         <p:nvSpPr>
-          <p:cNvPr id="12" name="TextBox 11"/>
+          <p:cNvPr id="13" name="TextBox 12"/>
           <p:cNvSpPr txBox="1"/>
           <p:nvPr/>
         </p:nvSpPr>
         <p:spPr>
           <a:xfrm>
-            <a:off x="868680" y="4370832"/>
-            <a:ext cx="5669280" cy="365760"/>
+            <a:off x="2789813" y="4389120"/>
+            <a:ext cx="3749039" cy="502920"/>
           </a:xfrm>
           <a:prstGeom prst="rect">
             <a:avLst/>
@@ -22606,7 +22635,7 @@
           <a:p>
             <a:pPr algn="l"/>
             <a:r>
-              <a:rPr sz="1350" b="0" i="0">
+              <a:rPr sz="1150" b="0" i="0">
                 <a:solidFill>
                   <a:srgbClr val="CED9E4"/>
                 </a:solidFill>
@@ -22619,14 +22648,14 @@
       </p:sp>
       <p:sp>
         <p:nvSpPr>
-          <p:cNvPr id="13" name="TextBox 12"/>
+          <p:cNvPr id="14" name="TextBox 13"/>
           <p:cNvSpPr txBox="1"/>
           <p:nvPr/>
         </p:nvSpPr>
         <p:spPr>
           <a:xfrm>
-            <a:off x="868680" y="4663440"/>
-            <a:ext cx="5669280" cy="365760"/>
+            <a:off x="2789813" y="4681728"/>
+            <a:ext cx="3749039" cy="502920"/>
           </a:xfrm>
           <a:prstGeom prst="rect">
             <a:avLst/>
@@ -22641,7 +22670,7 @@
           <a:p>
             <a:pPr algn="l"/>
             <a:r>
-              <a:rPr sz="1350" b="0" i="0">
+              <a:rPr sz="1150" b="0" i="0">
                 <a:solidFill>
                   <a:srgbClr val="CED9E4"/>
                 </a:solidFill>
@@ -22654,14 +22683,14 @@
       </p:sp>
       <p:sp>
         <p:nvSpPr>
-          <p:cNvPr id="14" name="TextBox 13"/>
+          <p:cNvPr id="15" name="TextBox 14"/>
           <p:cNvSpPr txBox="1"/>
           <p:nvPr/>
         </p:nvSpPr>
         <p:spPr>
           <a:xfrm>
-            <a:off x="868680" y="4956048"/>
-            <a:ext cx="5669280" cy="365760"/>
+            <a:off x="2789813" y="4974336"/>
+            <a:ext cx="3749039" cy="502920"/>
           </a:xfrm>
           <a:prstGeom prst="rect">
             <a:avLst/>
@@ -22676,7 +22705,7 @@
           <a:p>
             <a:pPr algn="l"/>
             <a:r>
-              <a:rPr sz="1350" b="0" i="0">
+              <a:rPr sz="1150" b="0" i="0">
                 <a:solidFill>
                   <a:srgbClr val="CED9E4"/>
                 </a:solidFill>
@@ -22689,7 +22718,7 @@
       </p:sp>
       <p:sp>
         <p:nvSpPr>
-          <p:cNvPr id="15" name="Rectangle 14"/>
+          <p:cNvPr id="16" name="Rectangle 15"/>
           <p:cNvSpPr/>
           <p:nvPr/>
         </p:nvSpPr>
@@ -22735,7 +22764,7 @@
       </p:sp>
       <p:sp>
         <p:nvSpPr>
-          <p:cNvPr id="16" name="TextBox 15"/>
+          <p:cNvPr id="17" name="TextBox 16"/>
           <p:cNvSpPr txBox="1"/>
           <p:nvPr/>
         </p:nvSpPr>
@@ -22770,7 +22799,7 @@
       </p:sp>
       <p:sp>
         <p:nvSpPr>
-          <p:cNvPr id="17" name="TextBox 16"/>
+          <p:cNvPr id="18" name="TextBox 17"/>
           <p:cNvSpPr txBox="1"/>
           <p:nvPr/>
         </p:nvSpPr>
@@ -22805,7 +22834,7 @@
       </p:sp>
       <p:sp>
         <p:nvSpPr>
-          <p:cNvPr id="18" name="TextBox 17"/>
+          <p:cNvPr id="19" name="TextBox 18"/>
           <p:cNvSpPr txBox="1"/>
           <p:nvPr/>
         </p:nvSpPr>
@@ -22840,7 +22869,7 @@
       </p:sp>
       <p:sp>
         <p:nvSpPr>
-          <p:cNvPr id="19" name="TextBox 18"/>
+          <p:cNvPr id="20" name="TextBox 19"/>
           <p:cNvSpPr txBox="1"/>
           <p:nvPr/>
         </p:nvSpPr>
@@ -22868,14 +22897,14 @@
                 </a:solidFill>
                 <a:latin typeface="Inter"/>
               </a:rPr>
-              <a:t>• Product: live demo, terrain risk map, grounded Q&amp;A with the 1+5 gate, deployment</a:t>
+              <a:t>• Product: live demo, terrain risk map, grounded Q&amp;A with the 1+5 gate</a:t>
             </a:r>
           </a:p>
         </p:txBody>
       </p:sp>
       <p:sp>
         <p:nvSpPr>
-          <p:cNvPr id="20" name="TextBox 19"/>
+          <p:cNvPr id="21" name="TextBox 20"/>
           <p:cNvSpPr txBox="1"/>
           <p:nvPr/>
         </p:nvSpPr>
@@ -22910,14 +22939,14 @@
       </p:sp>
       <p:sp>
         <p:nvSpPr>
-          <p:cNvPr id="21" name="TextBox 20"/>
+          <p:cNvPr id="22" name="TextBox 21"/>
           <p:cNvSpPr txBox="1"/>
           <p:nvPr/>
         </p:nvSpPr>
         <p:spPr>
           <a:xfrm>
-            <a:off x="868680" y="5989320"/>
-            <a:ext cx="10607040" cy="365760"/>
+            <a:off x="868680" y="6035040"/>
+            <a:ext cx="10789920" cy="365760"/>
           </a:xfrm>
           <a:prstGeom prst="rect">
             <a:avLst/>
@@ -22932,7 +22961,7 @@
           <a:p>
             <a:pPr algn="l"/>
             <a:r>
-              <a:rPr sz="1050" b="0" i="0">
+              <a:rPr sz="950" b="0" i="0">
                 <a:solidFill>
                   <a:srgbClr val="9FB4C6"/>
                 </a:solidFill>

</xml_diff>